<commit_message>
Use plain white slide backgrounds in presentation
Co-Authored-By: Claude Sonnet 5.5 <noreply@anthropic.com>
Claude-Session: https://claude.ai/code/session_01BwPusk3hw6BnsQN8UxBjGy
</commit_message>
<xml_diff>
--- a/SmartWaste_Presentation.pptx
+++ b/SmartWaste_Presentation.pptx
@@ -112,19 +112,19 @@
   <p:extLst>
     <p:ext uri="{521415D9-36F7-43E2-AB2F-B90AF26B5E84}">
       <p14:sectionLst xmlns:p14="http://schemas.microsoft.com/office/powerpoint/2010/main">
-        <p14:section name="Intro" id="{3e74ad40-9060-6d04-393f-b5fc7883992b}">
+        <p14:section name="Intro" id="{fd09f4a9-4ae3-a20b-2f5c-e1cd91ccb090}">
           <p14:sldIdLst>
             <p14:sldId id="256"/>
             <p14:sldId id="257"/>
           </p14:sldIdLst>
         </p14:section>
-        <p14:section name="Method" id="{8ce70757-58d2-5753-d0ea-941a230fdc3e}">
+        <p14:section name="Method" id="{12d7db54-cea2-d6e3-f6e7-739a561505e7}">
           <p14:sldIdLst>
             <p14:sldId id="258"/>
             <p14:sldId id="259"/>
           </p14:sldIdLst>
         </p14:section>
-        <p14:section name="Results" id="{2b74f7e4-6168-4fe7-9cbf-263aa19f5efd}">
+        <p14:section name="Results" id="{366ccaee-eb85-4541-a9b8-896009dd26b5}">
           <p14:sldIdLst>
             <p14:sldId id="260"/>
             <p14:sldId id="261"/>
@@ -365,7 +365,7 @@
           <c:spPr>
             <a:ln w="6350" cap="flat">
               <a:solidFill>
-                <a:srgbClr val="D5E3D9"/>
+                <a:srgbClr val="E0E3E0"/>
               </a:solidFill>
               <a:prstDash val="solid"/>
               <a:round/>
@@ -1342,7 +1342,7 @@
     <p:bg>
       <p:bgPr>
         <a:solidFill>
-          <a:schemeClr val="tx2"/>
+          <a:schemeClr val="bg1"/>
         </a:solidFill>
       </p:bgPr>
     </p:bg>
@@ -1374,7 +1374,7 @@
     <p:bg>
       <p:bgPr>
         <a:solidFill>
-          <a:schemeClr val="tx2"/>
+          <a:schemeClr val="bg1"/>
         </a:solidFill>
       </p:bgPr>
     </p:bg>
@@ -1418,7 +1418,7 @@
               <a:buNone/>
               <a:defRPr lang="en-US" sz="3600" b="1" dirty="0">
                 <a:solidFill>
-                  <a:schemeClr val="bg1"/>
+                  <a:schemeClr val="tx2"/>
                 </a:solidFill>
               </a:defRPr>
             </a:lvl1pPr>
@@ -1858,7 +1858,7 @@
             <a:r>
               <a:rPr lang="en-US" sz="4800" b="1" dirty="0">
                 <a:solidFill>
-                  <a:schemeClr val="bg1"/>
+                  <a:schemeClr val="tx2"/>
                 </a:solidFill>
                 <a:latin typeface="Cambria" pitchFamily="34" charset="0"/>
                 <a:ea typeface="Cambria" pitchFamily="34" charset="-122"/>
@@ -1897,7 +1897,7 @@
             <a:r>
               <a:rPr lang="en-US" sz="2000" dirty="0">
                 <a:solidFill>
-                  <a:schemeClr val="bg2"/>
+                  <a:schemeClr val="tx1"/>
                 </a:solidFill>
               </a:rPr>
               <a:t>AI waste classification that runs entirely in your browser</a:t>
@@ -1933,7 +1933,7 @@
             <a:r>
               <a:rPr lang="en-US" sz="1400" dirty="0">
                 <a:solidFill>
-                  <a:schemeClr val="accent6"/>
+                  <a:schemeClr val="accent4"/>
                 </a:solidFill>
               </a:rPr>
               <a:t>MobileNetV2 · ONNX Runtime Web · Next.js</a:t>
@@ -3102,11 +3102,11 @@
             </a:avLst>
           </a:prstGeom>
           <a:solidFill>
-            <a:schemeClr val="accent1"/>
+            <a:schemeClr val="bg2"/>
           </a:solidFill>
           <a:ln w="12700">
             <a:solidFill>
-              <a:schemeClr val="accent1"/>
+              <a:schemeClr val="bg2"/>
             </a:solidFill>
             <a:prstDash val="solid"/>
           </a:ln>
@@ -3163,7 +3163,7 @@
             <a:r>
               <a:rPr lang="en-US" sz="1800" b="1" dirty="0">
                 <a:solidFill>
-                  <a:schemeClr val="bg1"/>
+                  <a:schemeClr val="tx2"/>
                 </a:solidFill>
               </a:rPr>
               <a:t>Private by design: images never leave the device. No upload, no server.</a:t>
@@ -3962,7 +3962,7 @@
             <a:r>
               <a:rPr lang="en-US" sz="3600" b="1" dirty="0">
                 <a:solidFill>
-                  <a:schemeClr val="bg1"/>
+                  <a:schemeClr val="tx2"/>
                 </a:solidFill>
               </a:rPr>
               <a:t>Limitations and tech stack</a:t>
@@ -3998,7 +3998,7 @@
             <a:r>
               <a:rPr lang="en-US" sz="2000" b="1" dirty="0">
                 <a:solidFill>
-                  <a:schemeClr val="accent2"/>
+                  <a:schemeClr val="tx2"/>
                 </a:solidFill>
               </a:rPr>
               <a:t>Limitations</a:t>
@@ -4038,7 +4038,7 @@
             <a:r>
               <a:rPr lang="en-US" sz="1400" dirty="0">
                 <a:solidFill>
-                  <a:schemeClr val="bg1"/>
+                  <a:schemeClr val="tx1"/>
                 </a:solidFill>
               </a:rPr>
               <a:t>Only six categories: every image is assigned to one</a:t>
@@ -4056,7 +4056,7 @@
             <a:r>
               <a:rPr lang="en-US" sz="1400" dirty="0">
                 <a:solidFill>
-                  <a:schemeClr val="bg1"/>
+                  <a:schemeClr val="tx1"/>
                 </a:solidFill>
               </a:rPr>
               <a:t>Common errors: plastic vs. glass, metal vs. glass, cardboard vs. paper</a:t>
@@ -4074,7 +4074,7 @@
             <a:r>
               <a:rPr lang="en-US" sz="1400" dirty="0">
                 <a:solidFill>
-                  <a:schemeClr val="bg1"/>
+                  <a:schemeClr val="tx1"/>
                 </a:solidFill>
               </a:rPr>
               <a:t>Clutter, several items or poor light can fool it</a:t>
@@ -4092,7 +4092,7 @@
             <a:r>
               <a:rPr lang="en-US" sz="1400" dirty="0">
                 <a:solidFill>
-                  <a:schemeClr val="bg1"/>
+                  <a:schemeClr val="tx1"/>
                 </a:solidFill>
               </a:rPr>
               <a:t>Disposal rules vary by location</a:t>
@@ -4118,11 +4118,11 @@
             </a:avLst>
           </a:prstGeom>
           <a:solidFill>
-            <a:schemeClr val="accent1"/>
+            <a:schemeClr val="bg2"/>
           </a:solidFill>
           <a:ln w="12700">
             <a:solidFill>
-              <a:schemeClr val="accent1"/>
+              <a:schemeClr val="bg2"/>
             </a:solidFill>
             <a:prstDash val="solid"/>
           </a:ln>
@@ -4155,7 +4155,7 @@
             <a:r>
               <a:rPr lang="en-US" sz="2000" b="1" dirty="0">
                 <a:solidFill>
-                  <a:schemeClr val="bg1"/>
+                  <a:schemeClr val="tx2"/>
                 </a:solidFill>
               </a:rPr>
               <a:t>Built with</a:t>
@@ -4195,7 +4195,7 @@
             <a:r>
               <a:rPr lang="en-US" sz="1400" dirty="0">
                 <a:solidFill>
-                  <a:schemeClr val="bg1"/>
+                  <a:schemeClr val="tx1"/>
                 </a:solidFill>
               </a:rPr>
               <a:t>Next.js, React, TypeScript, Tailwind CSS</a:t>
@@ -4213,7 +4213,7 @@
             <a:r>
               <a:rPr lang="en-US" sz="1400" dirty="0">
                 <a:solidFill>
-                  <a:schemeClr val="bg1"/>
+                  <a:schemeClr val="tx1"/>
                 </a:solidFill>
               </a:rPr>
               <a:t>TensorFlow / Keras for training</a:t>
@@ -4231,7 +4231,7 @@
             <a:r>
               <a:rPr lang="en-US" sz="1400" dirty="0">
                 <a:solidFill>
-                  <a:schemeClr val="bg1"/>
+                  <a:schemeClr val="tx1"/>
                 </a:solidFill>
               </a:rPr>
               <a:t>ONNX Runtime Web for inference</a:t>
@@ -4249,7 +4249,7 @@
             <a:r>
               <a:rPr lang="en-US" sz="1400" dirty="0">
                 <a:solidFill>
-                  <a:schemeClr val="bg1"/>
+                  <a:schemeClr val="tx1"/>
                 </a:solidFill>
               </a:rPr>
               <a:t>Vercel for hosting</a:t>
@@ -4285,7 +4285,7 @@
             <a:r>
               <a:rPr lang="en-US" sz="1400" dirty="0">
                 <a:solidFill>
-                  <a:schemeClr val="bg2"/>
+                  <a:schemeClr val="accent4"/>
                 </a:solidFill>
               </a:rPr>
               <a:t>Live demo</a:t>
@@ -4323,7 +4323,7 @@
             <a:r>
               <a:rPr lang="en-US" sz="1800" b="1" u="sng" dirty="0">
                 <a:solidFill>
-                  <a:schemeClr val="bg1"/>
+                  <a:schemeClr val="accent1"/>
                 </a:solidFill>
                 <a:hlinkClick r:id="rId1" invalidUrl="" action="" tgtFrame="" tooltip="" history="1" highlightClick="0" endSnd="0">
                   <a:extLst>
@@ -4361,7 +4361,7 @@
         <a:srgbClr val="14532D"/>
       </a:dk2>
       <a:lt2>
-        <a:srgbClr val="EAF4EC"/>
+        <a:srgbClr val="F3F4F3"/>
       </a:lt2>
       <a:accent1>
         <a:srgbClr val="1F7F40"/>

</xml_diff>